<commit_message>
Rename Original/Standard to N/Z in display labels
Update all benchmark scripts to use "N/Z Circuit" and "N/Z Schedule"
terminology instead of "Original" or "Standard" for the traditional
N-shaped/Z-shaped syndrome extraction schedule.
</commit_message>
<xml_diff>
--- a/Diagonal Schedule.pptx
+++ b/Diagonal Schedule.pptx
@@ -1282,7 +1282,7 @@
           <a:p>
             <a:fld id="{49372E36-343A-6741-AAA5-4A4CC4BBC61B}" type="datetimeFigureOut">
               <a:rPr lang="en-IL" smtClean="0"/>
-              <a:t>10/01/2026</a:t>
+              <a:t>13/01/2026</a:t>
             </a:fld>
             <a:endParaRPr lang="en-IL"/>
           </a:p>
@@ -1594,6 +1594,90 @@
           <a:bodyPr/>
           <a:lstStyle/>
           <a:p>
+            <a:endParaRPr lang="en-IL" dirty="0"/>
+          </a:p>
+        </p:txBody>
+      </p:sp>
+      <p:sp>
+        <p:nvSpPr>
+          <p:cNvPr id="4" name="Slide Number Placeholder 3"/>
+          <p:cNvSpPr>
+            <a:spLocks noGrp="1"/>
+          </p:cNvSpPr>
+          <p:nvPr>
+            <p:ph type="sldNum" sz="quarter" idx="5"/>
+          </p:nvPr>
+        </p:nvSpPr>
+        <p:spPr/>
+        <p:txBody>
+          <a:bodyPr/>
+          <a:lstStyle/>
+          <a:p>
+            <a:fld id="{FF615906-8FEA-3045-9172-729FFF3A66A6}" type="slidenum">
+              <a:rPr lang="en-IL" smtClean="0"/>
+              <a:t>4</a:t>
+            </a:fld>
+            <a:endParaRPr lang="en-IL"/>
+          </a:p>
+        </p:txBody>
+      </p:sp>
+    </p:spTree>
+    <p:extLst>
+      <p:ext uri="{BB962C8B-B14F-4D97-AF65-F5344CB8AC3E}">
+        <p14:creationId xmlns:p14="http://schemas.microsoft.com/office/powerpoint/2010/main" val="548130300"/>
+      </p:ext>
+    </p:extLst>
+  </p:cSld>
+  <p:clrMapOvr>
+    <a:masterClrMapping/>
+  </p:clrMapOvr>
+</p:notes>
+</file>
+
+<file path=ppt/notesSlides/notesSlide2.xml><?xml version="1.0" encoding="utf-8"?>
+<p:notes xmlns:a="http://schemas.openxmlformats.org/drawingml/2006/main" xmlns:r="http://schemas.openxmlformats.org/officeDocument/2006/relationships" xmlns:p="http://schemas.openxmlformats.org/presentationml/2006/main">
+  <p:cSld>
+    <p:spTree>
+      <p:nvGrpSpPr>
+        <p:cNvPr id="1" name=""/>
+        <p:cNvGrpSpPr/>
+        <p:nvPr/>
+      </p:nvGrpSpPr>
+      <p:grpSpPr>
+        <a:xfrm>
+          <a:off x="0" y="0"/>
+          <a:ext cx="0" cy="0"/>
+          <a:chOff x="0" y="0"/>
+          <a:chExt cx="0" cy="0"/>
+        </a:xfrm>
+      </p:grpSpPr>
+      <p:sp>
+        <p:nvSpPr>
+          <p:cNvPr id="2" name="Slide Image Placeholder 1"/>
+          <p:cNvSpPr>
+            <a:spLocks noGrp="1" noRot="1" noChangeAspect="1"/>
+          </p:cNvSpPr>
+          <p:nvPr>
+            <p:ph type="sldImg"/>
+          </p:nvPr>
+        </p:nvSpPr>
+        <p:spPr/>
+      </p:sp>
+      <p:sp>
+        <p:nvSpPr>
+          <p:cNvPr id="3" name="Notes Placeholder 2"/>
+          <p:cNvSpPr>
+            <a:spLocks noGrp="1"/>
+          </p:cNvSpPr>
+          <p:nvPr>
+            <p:ph type="body" idx="1"/>
+          </p:nvPr>
+        </p:nvSpPr>
+        <p:spPr/>
+        <p:txBody>
+          <a:bodyPr/>
+          <a:lstStyle/>
+          <a:p>
             <a:pPr marL="0" marR="0" lvl="0" indent="0" algn="l" defTabSz="914400" rtl="0" eaLnBrk="1" fontAlgn="auto" latinLnBrk="0" hangingPunct="1">
               <a:lnSpc>
                 <a:spcPct val="100000"/>
@@ -1753,7 +1837,7 @@
 </p:notes>
 </file>
 
-<file path=ppt/notesSlides/notesSlide2.xml><?xml version="1.0" encoding="utf-8"?>
+<file path=ppt/notesSlides/notesSlide3.xml><?xml version="1.0" encoding="utf-8"?>
 <p:notes xmlns:a="http://schemas.openxmlformats.org/drawingml/2006/main" xmlns:r="http://schemas.openxmlformats.org/officeDocument/2006/relationships" xmlns:p="http://schemas.openxmlformats.org/presentationml/2006/main">
   <p:cSld>
     <p:spTree>
@@ -1857,7 +1941,7 @@
 </p:notes>
 </file>
 
-<file path=ppt/notesSlides/notesSlide3.xml><?xml version="1.0" encoding="utf-8"?>
+<file path=ppt/notesSlides/notesSlide4.xml><?xml version="1.0" encoding="utf-8"?>
 <p:notes xmlns:a="http://schemas.openxmlformats.org/drawingml/2006/main" xmlns:r="http://schemas.openxmlformats.org/officeDocument/2006/relationships" xmlns:p="http://schemas.openxmlformats.org/presentationml/2006/main">
   <p:cSld>
     <p:spTree>
@@ -2006,7 +2090,7 @@
 </p:notes>
 </file>
 
-<file path=ppt/notesSlides/notesSlide4.xml><?xml version="1.0" encoding="utf-8"?>
+<file path=ppt/notesSlides/notesSlide5.xml><?xml version="1.0" encoding="utf-8"?>
 <p:notes xmlns:a="http://schemas.openxmlformats.org/drawingml/2006/main" xmlns:r="http://schemas.openxmlformats.org/officeDocument/2006/relationships" xmlns:p="http://schemas.openxmlformats.org/presentationml/2006/main">
   <p:cSld>
     <p:spTree>
@@ -2090,7 +2174,7 @@
 </p:notes>
 </file>
 
-<file path=ppt/notesSlides/notesSlide5.xml><?xml version="1.0" encoding="utf-8"?>
+<file path=ppt/notesSlides/notesSlide6.xml><?xml version="1.0" encoding="utf-8"?>
 <p:notes xmlns:a="http://schemas.openxmlformats.org/drawingml/2006/main" xmlns:r="http://schemas.openxmlformats.org/officeDocument/2006/relationships" xmlns:p="http://schemas.openxmlformats.org/presentationml/2006/main">
   <p:cSld>
     <p:spTree>
@@ -2323,7 +2407,7 @@
           <a:p>
             <a:fld id="{EA40BB8E-62FA-0445-A282-ED22967A1017}" type="datetimeFigureOut">
               <a:rPr lang="en-IL" smtClean="0"/>
-              <a:t>10/01/2026</a:t>
+              <a:t>13/01/2026</a:t>
             </a:fld>
             <a:endParaRPr lang="en-IL"/>
           </a:p>
@@ -2523,7 +2607,7 @@
           <a:p>
             <a:fld id="{EA40BB8E-62FA-0445-A282-ED22967A1017}" type="datetimeFigureOut">
               <a:rPr lang="en-IL" smtClean="0"/>
-              <a:t>10/01/2026</a:t>
+              <a:t>13/01/2026</a:t>
             </a:fld>
             <a:endParaRPr lang="en-IL"/>
           </a:p>
@@ -2733,7 +2817,7 @@
           <a:p>
             <a:fld id="{EA40BB8E-62FA-0445-A282-ED22967A1017}" type="datetimeFigureOut">
               <a:rPr lang="en-IL" smtClean="0"/>
-              <a:t>10/01/2026</a:t>
+              <a:t>13/01/2026</a:t>
             </a:fld>
             <a:endParaRPr lang="en-IL"/>
           </a:p>
@@ -2933,7 +3017,7 @@
           <a:p>
             <a:fld id="{EA40BB8E-62FA-0445-A282-ED22967A1017}" type="datetimeFigureOut">
               <a:rPr lang="en-IL" smtClean="0"/>
-              <a:t>10/01/2026</a:t>
+              <a:t>13/01/2026</a:t>
             </a:fld>
             <a:endParaRPr lang="en-IL"/>
           </a:p>
@@ -3209,7 +3293,7 @@
           <a:p>
             <a:fld id="{EA40BB8E-62FA-0445-A282-ED22967A1017}" type="datetimeFigureOut">
               <a:rPr lang="en-IL" smtClean="0"/>
-              <a:t>10/01/2026</a:t>
+              <a:t>13/01/2026</a:t>
             </a:fld>
             <a:endParaRPr lang="en-IL"/>
           </a:p>
@@ -3477,7 +3561,7 @@
           <a:p>
             <a:fld id="{EA40BB8E-62FA-0445-A282-ED22967A1017}" type="datetimeFigureOut">
               <a:rPr lang="en-IL" smtClean="0"/>
-              <a:t>10/01/2026</a:t>
+              <a:t>13/01/2026</a:t>
             </a:fld>
             <a:endParaRPr lang="en-IL"/>
           </a:p>
@@ -3892,7 +3976,7 @@
           <a:p>
             <a:fld id="{EA40BB8E-62FA-0445-A282-ED22967A1017}" type="datetimeFigureOut">
               <a:rPr lang="en-IL" smtClean="0"/>
-              <a:t>10/01/2026</a:t>
+              <a:t>13/01/2026</a:t>
             </a:fld>
             <a:endParaRPr lang="en-IL"/>
           </a:p>
@@ -4034,7 +4118,7 @@
           <a:p>
             <a:fld id="{EA40BB8E-62FA-0445-A282-ED22967A1017}" type="datetimeFigureOut">
               <a:rPr lang="en-IL" smtClean="0"/>
-              <a:t>10/01/2026</a:t>
+              <a:t>13/01/2026</a:t>
             </a:fld>
             <a:endParaRPr lang="en-IL"/>
           </a:p>
@@ -4147,7 +4231,7 @@
           <a:p>
             <a:fld id="{EA40BB8E-62FA-0445-A282-ED22967A1017}" type="datetimeFigureOut">
               <a:rPr lang="en-IL" smtClean="0"/>
-              <a:t>10/01/2026</a:t>
+              <a:t>13/01/2026</a:t>
             </a:fld>
             <a:endParaRPr lang="en-IL"/>
           </a:p>
@@ -4460,7 +4544,7 @@
           <a:p>
             <a:fld id="{EA40BB8E-62FA-0445-A282-ED22967A1017}" type="datetimeFigureOut">
               <a:rPr lang="en-IL" smtClean="0"/>
-              <a:t>10/01/2026</a:t>
+              <a:t>13/01/2026</a:t>
             </a:fld>
             <a:endParaRPr lang="en-IL"/>
           </a:p>
@@ -4749,7 +4833,7 @@
           <a:p>
             <a:fld id="{EA40BB8E-62FA-0445-A282-ED22967A1017}" type="datetimeFigureOut">
               <a:rPr lang="en-IL" smtClean="0"/>
-              <a:t>10/01/2026</a:t>
+              <a:t>13/01/2026</a:t>
             </a:fld>
             <a:endParaRPr lang="en-IL"/>
           </a:p>
@@ -4992,7 +5076,7 @@
           <a:p>
             <a:fld id="{EA40BB8E-62FA-0445-A282-ED22967A1017}" type="datetimeFigureOut">
               <a:rPr lang="en-IL" smtClean="0"/>
-              <a:t>10/01/2026</a:t>
+              <a:t>13/01/2026</a:t>
             </a:fld>
             <a:endParaRPr lang="en-IL"/>
           </a:p>
@@ -23773,7 +23857,7 @@
           </p:nvPr>
         </p:nvPicPr>
         <p:blipFill>
-          <a:blip r:embed="rId2"/>
+          <a:blip r:embed="rId3"/>
           <a:stretch>
             <a:fillRect/>
           </a:stretch>
@@ -23800,7 +23884,7 @@
           <p:nvPr/>
         </p:nvPicPr>
         <p:blipFill>
-          <a:blip r:embed="rId3"/>
+          <a:blip r:embed="rId4"/>
           <a:stretch>
             <a:fillRect/>
           </a:stretch>
@@ -24131,10 +24215,10 @@
       </p:sp>
       <p:pic>
         <p:nvPicPr>
-          <p:cNvPr id="22" name="Picture 21">
+          <p:cNvPr id="4" name="Picture 3">
             <a:extLst>
               <a:ext uri="{FF2B5EF4-FFF2-40B4-BE49-F238E27FC236}">
-                <a16:creationId xmlns:a16="http://schemas.microsoft.com/office/drawing/2014/main" id="{0F022656-7572-6285-024A-FC86E79D6C2F}"/>
+                <a16:creationId xmlns:a16="http://schemas.microsoft.com/office/drawing/2014/main" id="{8113EEB1-FFE2-6E2F-52A3-CD3A7C75D37C}"/>
               </a:ext>
             </a:extLst>
           </p:cNvPr>
@@ -24151,8 +24235,8 @@
         </p:blipFill>
         <p:spPr>
           <a:xfrm>
-            <a:off x="6096000" y="2242761"/>
-            <a:ext cx="5860950" cy="4376905"/>
+            <a:off x="6064470" y="2305560"/>
+            <a:ext cx="6096000" cy="4552439"/>
           </a:xfrm>
           <a:prstGeom prst="rect">
             <a:avLst/>
@@ -24429,10 +24513,10 @@
       </p:sp>
       <p:pic>
         <p:nvPicPr>
-          <p:cNvPr id="18" name="Picture 17">
+          <p:cNvPr id="6" name="Picture 5">
             <a:extLst>
               <a:ext uri="{FF2B5EF4-FFF2-40B4-BE49-F238E27FC236}">
-                <a16:creationId xmlns:a16="http://schemas.microsoft.com/office/drawing/2014/main" id="{AB98D059-E0D8-BA61-6EBB-7C289FAC07D7}"/>
+                <a16:creationId xmlns:a16="http://schemas.microsoft.com/office/drawing/2014/main" id="{9C0B7C48-FC86-972C-9A71-D09DCC692D46}"/>
               </a:ext>
             </a:extLst>
           </p:cNvPr>
@@ -24449,8 +24533,8 @@
         </p:blipFill>
         <p:spPr>
           <a:xfrm>
-            <a:off x="5710551" y="1872965"/>
-            <a:ext cx="6375911" cy="4761473"/>
+            <a:off x="5769502" y="2001735"/>
+            <a:ext cx="6422497" cy="4796264"/>
           </a:xfrm>
           <a:prstGeom prst="rect">
             <a:avLst/>
@@ -25278,8 +25362,8 @@
           </p:sp>
         </mc:Fallback>
       </mc:AlternateContent>
-      <mc:AlternateContent xmlns:mc="http://schemas.openxmlformats.org/markup-compatibility/2006">
-        <mc:Choice xmlns:a14="http://schemas.microsoft.com/office/drawing/2010/main" Requires="a14">
+      <mc:AlternateContent xmlns:mc="http://schemas.openxmlformats.org/markup-compatibility/2006" xmlns:a14="http://schemas.microsoft.com/office/drawing/2010/main">
+        <mc:Choice Requires="a14">
           <p:sp>
             <p:nvSpPr>
               <p:cNvPr id="600" name="TextBox 599">
@@ -25351,7 +25435,7 @@
             </p:txBody>
           </p:sp>
         </mc:Choice>
-        <mc:Fallback>
+        <mc:Fallback xmlns="">
           <p:sp>
             <p:nvSpPr>
               <p:cNvPr id="600" name="TextBox 599">
@@ -25396,8 +25480,8 @@
           </p:sp>
         </mc:Fallback>
       </mc:AlternateContent>
-      <mc:AlternateContent xmlns:mc="http://schemas.openxmlformats.org/markup-compatibility/2006">
-        <mc:Choice xmlns:a14="http://schemas.microsoft.com/office/drawing/2010/main" Requires="a14">
+      <mc:AlternateContent xmlns:mc="http://schemas.openxmlformats.org/markup-compatibility/2006" xmlns:a14="http://schemas.microsoft.com/office/drawing/2010/main">
+        <mc:Choice Requires="a14">
           <p:sp>
             <p:nvSpPr>
               <p:cNvPr id="601" name="TextBox 600">
@@ -25469,7 +25553,7 @@
             </p:txBody>
           </p:sp>
         </mc:Choice>
-        <mc:Fallback>
+        <mc:Fallback xmlns="">
           <p:sp>
             <p:nvSpPr>
               <p:cNvPr id="601" name="TextBox 600">
@@ -25514,8 +25598,8 @@
           </p:sp>
         </mc:Fallback>
       </mc:AlternateContent>
-      <mc:AlternateContent xmlns:mc="http://schemas.openxmlformats.org/markup-compatibility/2006">
-        <mc:Choice xmlns:a14="http://schemas.microsoft.com/office/drawing/2010/main" Requires="a14">
+      <mc:AlternateContent xmlns:mc="http://schemas.openxmlformats.org/markup-compatibility/2006" xmlns:a14="http://schemas.microsoft.com/office/drawing/2010/main">
+        <mc:Choice Requires="a14">
           <p:sp>
             <p:nvSpPr>
               <p:cNvPr id="603" name="TextBox 602">
@@ -25587,7 +25671,7 @@
             </p:txBody>
           </p:sp>
         </mc:Choice>
-        <mc:Fallback>
+        <mc:Fallback xmlns="">
           <p:sp>
             <p:nvSpPr>
               <p:cNvPr id="603" name="TextBox 602">
@@ -25632,8 +25716,8 @@
           </p:sp>
         </mc:Fallback>
       </mc:AlternateContent>
-      <mc:AlternateContent xmlns:mc="http://schemas.openxmlformats.org/markup-compatibility/2006">
-        <mc:Choice xmlns:a14="http://schemas.microsoft.com/office/drawing/2010/main" Requires="a14">
+      <mc:AlternateContent xmlns:mc="http://schemas.openxmlformats.org/markup-compatibility/2006" xmlns:a14="http://schemas.microsoft.com/office/drawing/2010/main">
+        <mc:Choice Requires="a14">
           <p:sp>
             <p:nvSpPr>
               <p:cNvPr id="604" name="TextBox 603">
@@ -25705,7 +25789,7 @@
             </p:txBody>
           </p:sp>
         </mc:Choice>
-        <mc:Fallback>
+        <mc:Fallback xmlns="">
           <p:sp>
             <p:nvSpPr>
               <p:cNvPr id="604" name="TextBox 603">
@@ -25750,8 +25834,8 @@
           </p:sp>
         </mc:Fallback>
       </mc:AlternateContent>
-      <mc:AlternateContent xmlns:mc="http://schemas.openxmlformats.org/markup-compatibility/2006">
-        <mc:Choice xmlns:a14="http://schemas.microsoft.com/office/drawing/2010/main" Requires="a14">
+      <mc:AlternateContent xmlns:mc="http://schemas.openxmlformats.org/markup-compatibility/2006" xmlns:a14="http://schemas.microsoft.com/office/drawing/2010/main">
+        <mc:Choice Requires="a14">
           <p:sp>
             <p:nvSpPr>
               <p:cNvPr id="605" name="TextBox 604">
@@ -25823,7 +25907,7 @@
             </p:txBody>
           </p:sp>
         </mc:Choice>
-        <mc:Fallback>
+        <mc:Fallback xmlns="">
           <p:sp>
             <p:nvSpPr>
               <p:cNvPr id="605" name="TextBox 604">

</xml_diff>

<commit_message>
Improve benchmark plots and plaquette visualizations
- Increase font sizes in all benchmark plots for paper readability
- Standardize figure sizes and legend positions across plots
- Add standalone PDF exports for each panel in spatial Hadamard and patch rotation plots
- Add schedule order line with arrow to plaquette SVGs showing CNOT sequence
- Remove separating lines in stretched plaquettes for cleaner appearance
- Transpose plaquette comparison layout to 3 rows x 2 columns (Z left, X right)
</commit_message>
<xml_diff>
--- a/Diagonal Schedule.pptx
+++ b/Diagonal Schedule.pptx
@@ -26088,7 +26088,7 @@
           <a:bodyPr/>
           <a:lstStyle/>
           <a:p>
-            <a:endParaRPr lang="en-IL"/>
+            <a:endParaRPr lang="en-IL" dirty="0"/>
           </a:p>
         </p:txBody>
       </p:sp>
@@ -26288,10 +26288,13 @@
           </a:prstGeom>
           <a:gradFill flip="none" rotWithShape="1">
             <a:gsLst>
+              <a:gs pos="30000">
+                <a:srgbClr val="FE9D99"/>
+              </a:gs>
               <a:gs pos="0">
                 <a:srgbClr val="FF9D98"/>
               </a:gs>
-              <a:gs pos="100000">
+              <a:gs pos="74000">
                 <a:srgbClr val="ACBFE5"/>
               </a:gs>
             </a:gsLst>

</xml_diff>

<commit_message>
Update diagonal schedule slides.
</commit_message>
<xml_diff>
--- a/Diagonal Schedule.pptx
+++ b/Diagonal Schedule.pptx
@@ -1282,7 +1282,7 @@
           <a:p>
             <a:fld id="{49372E36-343A-6741-AAA5-4A4CC4BBC61B}" type="datetimeFigureOut">
               <a:rPr lang="en-IL" smtClean="0"/>
-              <a:t>13/01/2026</a:t>
+              <a:t>28/01/2026</a:t>
             </a:fld>
             <a:endParaRPr lang="en-IL"/>
           </a:p>
@@ -2407,7 +2407,7 @@
           <a:p>
             <a:fld id="{EA40BB8E-62FA-0445-A282-ED22967A1017}" type="datetimeFigureOut">
               <a:rPr lang="en-IL" smtClean="0"/>
-              <a:t>13/01/2026</a:t>
+              <a:t>28/01/2026</a:t>
             </a:fld>
             <a:endParaRPr lang="en-IL"/>
           </a:p>
@@ -2607,7 +2607,7 @@
           <a:p>
             <a:fld id="{EA40BB8E-62FA-0445-A282-ED22967A1017}" type="datetimeFigureOut">
               <a:rPr lang="en-IL" smtClean="0"/>
-              <a:t>13/01/2026</a:t>
+              <a:t>28/01/2026</a:t>
             </a:fld>
             <a:endParaRPr lang="en-IL"/>
           </a:p>
@@ -2817,7 +2817,7 @@
           <a:p>
             <a:fld id="{EA40BB8E-62FA-0445-A282-ED22967A1017}" type="datetimeFigureOut">
               <a:rPr lang="en-IL" smtClean="0"/>
-              <a:t>13/01/2026</a:t>
+              <a:t>28/01/2026</a:t>
             </a:fld>
             <a:endParaRPr lang="en-IL"/>
           </a:p>
@@ -3017,7 +3017,7 @@
           <a:p>
             <a:fld id="{EA40BB8E-62FA-0445-A282-ED22967A1017}" type="datetimeFigureOut">
               <a:rPr lang="en-IL" smtClean="0"/>
-              <a:t>13/01/2026</a:t>
+              <a:t>28/01/2026</a:t>
             </a:fld>
             <a:endParaRPr lang="en-IL"/>
           </a:p>
@@ -3293,7 +3293,7 @@
           <a:p>
             <a:fld id="{EA40BB8E-62FA-0445-A282-ED22967A1017}" type="datetimeFigureOut">
               <a:rPr lang="en-IL" smtClean="0"/>
-              <a:t>13/01/2026</a:t>
+              <a:t>28/01/2026</a:t>
             </a:fld>
             <a:endParaRPr lang="en-IL"/>
           </a:p>
@@ -3561,7 +3561,7 @@
           <a:p>
             <a:fld id="{EA40BB8E-62FA-0445-A282-ED22967A1017}" type="datetimeFigureOut">
               <a:rPr lang="en-IL" smtClean="0"/>
-              <a:t>13/01/2026</a:t>
+              <a:t>28/01/2026</a:t>
             </a:fld>
             <a:endParaRPr lang="en-IL"/>
           </a:p>
@@ -3976,7 +3976,7 @@
           <a:p>
             <a:fld id="{EA40BB8E-62FA-0445-A282-ED22967A1017}" type="datetimeFigureOut">
               <a:rPr lang="en-IL" smtClean="0"/>
-              <a:t>13/01/2026</a:t>
+              <a:t>28/01/2026</a:t>
             </a:fld>
             <a:endParaRPr lang="en-IL"/>
           </a:p>
@@ -4118,7 +4118,7 @@
           <a:p>
             <a:fld id="{EA40BB8E-62FA-0445-A282-ED22967A1017}" type="datetimeFigureOut">
               <a:rPr lang="en-IL" smtClean="0"/>
-              <a:t>13/01/2026</a:t>
+              <a:t>28/01/2026</a:t>
             </a:fld>
             <a:endParaRPr lang="en-IL"/>
           </a:p>
@@ -4231,7 +4231,7 @@
           <a:p>
             <a:fld id="{EA40BB8E-62FA-0445-A282-ED22967A1017}" type="datetimeFigureOut">
               <a:rPr lang="en-IL" smtClean="0"/>
-              <a:t>13/01/2026</a:t>
+              <a:t>28/01/2026</a:t>
             </a:fld>
             <a:endParaRPr lang="en-IL"/>
           </a:p>
@@ -4544,7 +4544,7 @@
           <a:p>
             <a:fld id="{EA40BB8E-62FA-0445-A282-ED22967A1017}" type="datetimeFigureOut">
               <a:rPr lang="en-IL" smtClean="0"/>
-              <a:t>13/01/2026</a:t>
+              <a:t>28/01/2026</a:t>
             </a:fld>
             <a:endParaRPr lang="en-IL"/>
           </a:p>
@@ -4833,7 +4833,7 @@
           <a:p>
             <a:fld id="{EA40BB8E-62FA-0445-A282-ED22967A1017}" type="datetimeFigureOut">
               <a:rPr lang="en-IL" smtClean="0"/>
-              <a:t>13/01/2026</a:t>
+              <a:t>28/01/2026</a:t>
             </a:fld>
             <a:endParaRPr lang="en-IL"/>
           </a:p>
@@ -5076,7 +5076,7 @@
           <a:p>
             <a:fld id="{EA40BB8E-62FA-0445-A282-ED22967A1017}" type="datetimeFigureOut">
               <a:rPr lang="en-IL" smtClean="0"/>
-              <a:t>13/01/2026</a:t>
+              <a:t>28/01/2026</a:t>
             </a:fld>
             <a:endParaRPr lang="en-IL"/>
           </a:p>
@@ -5550,9 +5550,10 @@
           <a:lstStyle/>
           <a:p>
             <a:r>
-              <a:rPr lang="en-IL" dirty="0"/>
-              <a:t>Gilad Kishony</a:t>
+              <a:rPr lang="en-IL"/>
+              <a:t>Gilad Kishony and Austin Fowler</a:t>
             </a:r>
+            <a:endParaRPr lang="en-IL" dirty="0"/>
           </a:p>
         </p:txBody>
       </p:sp>

</xml_diff>

<commit_message>
Update rectangular memory data, interface plaquette, and plot script
</commit_message>
<xml_diff>
--- a/Diagonal Schedule.pptx
+++ b/Diagonal Schedule.pptx
@@ -1282,7 +1282,7 @@
           <a:p>
             <a:fld id="{49372E36-343A-6741-AAA5-4A4CC4BBC61B}" type="datetimeFigureOut">
               <a:rPr lang="en-IL" smtClean="0"/>
-              <a:t>28/01/2026</a:t>
+              <a:t>29/01/2026</a:t>
             </a:fld>
             <a:endParaRPr lang="en-IL"/>
           </a:p>
@@ -2407,7 +2407,7 @@
           <a:p>
             <a:fld id="{EA40BB8E-62FA-0445-A282-ED22967A1017}" type="datetimeFigureOut">
               <a:rPr lang="en-IL" smtClean="0"/>
-              <a:t>28/01/2026</a:t>
+              <a:t>29/01/2026</a:t>
             </a:fld>
             <a:endParaRPr lang="en-IL"/>
           </a:p>
@@ -2607,7 +2607,7 @@
           <a:p>
             <a:fld id="{EA40BB8E-62FA-0445-A282-ED22967A1017}" type="datetimeFigureOut">
               <a:rPr lang="en-IL" smtClean="0"/>
-              <a:t>28/01/2026</a:t>
+              <a:t>29/01/2026</a:t>
             </a:fld>
             <a:endParaRPr lang="en-IL"/>
           </a:p>
@@ -2817,7 +2817,7 @@
           <a:p>
             <a:fld id="{EA40BB8E-62FA-0445-A282-ED22967A1017}" type="datetimeFigureOut">
               <a:rPr lang="en-IL" smtClean="0"/>
-              <a:t>28/01/2026</a:t>
+              <a:t>29/01/2026</a:t>
             </a:fld>
             <a:endParaRPr lang="en-IL"/>
           </a:p>
@@ -3017,7 +3017,7 @@
           <a:p>
             <a:fld id="{EA40BB8E-62FA-0445-A282-ED22967A1017}" type="datetimeFigureOut">
               <a:rPr lang="en-IL" smtClean="0"/>
-              <a:t>28/01/2026</a:t>
+              <a:t>29/01/2026</a:t>
             </a:fld>
             <a:endParaRPr lang="en-IL"/>
           </a:p>
@@ -3293,7 +3293,7 @@
           <a:p>
             <a:fld id="{EA40BB8E-62FA-0445-A282-ED22967A1017}" type="datetimeFigureOut">
               <a:rPr lang="en-IL" smtClean="0"/>
-              <a:t>28/01/2026</a:t>
+              <a:t>29/01/2026</a:t>
             </a:fld>
             <a:endParaRPr lang="en-IL"/>
           </a:p>
@@ -3561,7 +3561,7 @@
           <a:p>
             <a:fld id="{EA40BB8E-62FA-0445-A282-ED22967A1017}" type="datetimeFigureOut">
               <a:rPr lang="en-IL" smtClean="0"/>
-              <a:t>28/01/2026</a:t>
+              <a:t>29/01/2026</a:t>
             </a:fld>
             <a:endParaRPr lang="en-IL"/>
           </a:p>
@@ -3976,7 +3976,7 @@
           <a:p>
             <a:fld id="{EA40BB8E-62FA-0445-A282-ED22967A1017}" type="datetimeFigureOut">
               <a:rPr lang="en-IL" smtClean="0"/>
-              <a:t>28/01/2026</a:t>
+              <a:t>29/01/2026</a:t>
             </a:fld>
             <a:endParaRPr lang="en-IL"/>
           </a:p>
@@ -4118,7 +4118,7 @@
           <a:p>
             <a:fld id="{EA40BB8E-62FA-0445-A282-ED22967A1017}" type="datetimeFigureOut">
               <a:rPr lang="en-IL" smtClean="0"/>
-              <a:t>28/01/2026</a:t>
+              <a:t>29/01/2026</a:t>
             </a:fld>
             <a:endParaRPr lang="en-IL"/>
           </a:p>
@@ -4231,7 +4231,7 @@
           <a:p>
             <a:fld id="{EA40BB8E-62FA-0445-A282-ED22967A1017}" type="datetimeFigureOut">
               <a:rPr lang="en-IL" smtClean="0"/>
-              <a:t>28/01/2026</a:t>
+              <a:t>29/01/2026</a:t>
             </a:fld>
             <a:endParaRPr lang="en-IL"/>
           </a:p>
@@ -4544,7 +4544,7 @@
           <a:p>
             <a:fld id="{EA40BB8E-62FA-0445-A282-ED22967A1017}" type="datetimeFigureOut">
               <a:rPr lang="en-IL" smtClean="0"/>
-              <a:t>28/01/2026</a:t>
+              <a:t>29/01/2026</a:t>
             </a:fld>
             <a:endParaRPr lang="en-IL"/>
           </a:p>
@@ -4833,7 +4833,7 @@
           <a:p>
             <a:fld id="{EA40BB8E-62FA-0445-A282-ED22967A1017}" type="datetimeFigureOut">
               <a:rPr lang="en-IL" smtClean="0"/>
-              <a:t>28/01/2026</a:t>
+              <a:t>29/01/2026</a:t>
             </a:fld>
             <a:endParaRPr lang="en-IL"/>
           </a:p>
@@ -5076,7 +5076,7 @@
           <a:p>
             <a:fld id="{EA40BB8E-62FA-0445-A282-ED22967A1017}" type="datetimeFigureOut">
               <a:rPr lang="en-IL" smtClean="0"/>
-              <a:t>28/01/2026</a:t>
+              <a:t>29/01/2026</a:t>
             </a:fld>
             <a:endParaRPr lang="en-IL"/>
           </a:p>
@@ -16649,7 +16649,7 @@
         <p:spPr>
           <a:xfrm>
             <a:off x="336007" y="3756122"/>
-            <a:ext cx="3977756" cy="369332"/>
+            <a:ext cx="3977756" cy="646331"/>
           </a:xfrm>
           <a:prstGeom prst="rect">
             <a:avLst/>
@@ -16664,8 +16664,20 @@
           <a:p>
             <a:r>
               <a:rPr lang="en-IL" dirty="0"/>
-              <a:t>Note: no single hook error is responsible</a:t>
+              <a:t>Note: no single hook error </a:t>
             </a:r>
+            <a:r>
+              <a:rPr lang="en-IL"/>
+              <a:t>is responsible</a:t>
+            </a:r>
+            <a:br>
+              <a:rPr lang="en-IL"/>
+            </a:br>
+            <a:r>
+              <a:rPr lang="en-IL"/>
+              <a:t>”fractional hook error”</a:t>
+            </a:r>
+            <a:endParaRPr lang="en-IL" dirty="0"/>
           </a:p>
         </p:txBody>
       </p:sp>

</xml_diff>